<commit_message>
Ajusta presentaciones/Taller_Practico_2.pptx: tiempos de agenda y fecha de entrega en la sesion 2
</commit_message>
<xml_diff>
--- a/presentaciones/Taller_Practico_2.pptx
+++ b/presentaciones/Taller_Practico_2.pptx
@@ -1223,7 +1223,7 @@
           <a:p>
             <a:r>
               <a:rPr lang="en-US" dirty="0"/>
-              <a:t>Di en voz alta: dominio libre, hay plantilla, y hay que entregarlo EJECUTADO. Define y anuncia la fecha de entrega.</a:t>
+              <a:t>Di en voz alta: dominio libre, hay plantilla (03_Tarea_Plantilla), y hay que entregarlo EJECUTADO. Fecha de entrega: lunes 14 de septiembre de 2026, 23:00. Ya está puesta en el campus.</a:t>
             </a:r>
             <a:endParaRPr lang="en-US" dirty="0"/>
           </a:p>
@@ -8652,7 +8652,7 @@
                 <a:ea typeface="Arial" pitchFamily="34" charset="-122"/>
                 <a:cs typeface="Arial" pitchFamily="34" charset="-120"/>
               </a:rPr>
-              <a:t>Dominio libre · 100 puntos, el 100% de la nota del curso</a:t>
+              <a:t>Dominio libre · 100 puntos = 100% de la nota · Entrega: lunes 14 de septiembre, 23:00</a:t>
             </a:r>
             <a:endParaRPr lang="en-US" sz="1400" dirty="0"/>
           </a:p>
@@ -11852,7 +11852,7 @@
                 <a:ea typeface="Arial" pitchFamily="34" charset="-122"/>
                 <a:cs typeface="Arial" pitchFamily="34" charset="-120"/>
               </a:rPr>
-              <a:t>Por qué olvida y cómo hacer que recuerde  ·  15 min</a:t>
+              <a:t>Por qué olvida y cómo hacer que recuerde  ·  13 min</a:t>
             </a:r>
             <a:endParaRPr lang="en-US" sz="1000" dirty="0"/>
           </a:p>
@@ -12027,7 +12027,7 @@
                 <a:ea typeface="Arial" pitchFamily="34" charset="-122"/>
                 <a:cs typeface="Arial" pitchFamily="34" charset="-120"/>
               </a:rPr>
-              <a:t>Los tres tipos, y cuál es el que de verdad protege  ·  15 min</a:t>
+              <a:t>Los tres tipos, y cuál es el que de verdad protege  ·  10 min</a:t>
             </a:r>
             <a:endParaRPr lang="en-US" sz="1000" dirty="0"/>
           </a:p>
@@ -12202,7 +12202,7 @@
                 <a:ea typeface="Arial" pitchFamily="34" charset="-122"/>
                 <a:cs typeface="Arial" pitchFamily="34" charset="-120"/>
               </a:rPr>
-              <a:t>Una cuarta herramienta y el encargo evaluado  ·  10 min</a:t>
+              <a:t>Una cuarta herramienta y el encargo evaluado  ·  12 min</a:t>
             </a:r>
             <a:endParaRPr lang="en-US" sz="1000" dirty="0"/>
           </a:p>

</xml_diff>

<commit_message>
Sesion 2: numero de resultados de Open Library al dia y nota sobre su variacion (presentaciones/Taller_Practico_2.pptx)
</commit_message>
<xml_diff>
--- a/presentaciones/Taller_Practico_2.pptx
+++ b/presentaciones/Taller_Practico_2.pptx
@@ -1839,7 +1839,7 @@
           <a:p>
             <a:r>
               <a:rPr lang="en-US" dirty="0"/>
-              <a:t>Detén la clase aquí y señala los DOS Invoking. Es el concepto central de la sesión. Si a alguien le salió distinto, úsalo para hablar de alucinación.</a:t>
+              <a:t>Detén la clase aquí y señala los DOS Invoking. Es el concepto central de la sesión. Si a alguien le salió distinto, úsalo para hablar de alucinación. OJO: el número de resultados cambia cada día porque es una consulta real a Open Library. Si en pantalla sale otro, dilo en voz alta: es la prueba de que no está simulado.</a:t>
             </a:r>
             <a:endParaRPr lang="en-US" dirty="0"/>
           </a:p>
@@ -14528,7 +14528,7 @@
                 <a:ea typeface="Courier New" pitchFamily="34" charset="-122"/>
                 <a:cs typeface="Courier New" pitchFamily="34" charset="-120"/>
               </a:rPr>
-              <a:t>  Encontre 2320 resultados: Sapiens de Yuval Noah Harari, 2011</a:t>
+              <a:t>  Encontre 2318 resultados: Sapiens de Yuval Noah Harari, 2011</a:t>
             </a:r>
             <a:endParaRPr lang="en-US" sz="1150" dirty="0"/>
           </a:p>

</xml_diff>